<commit_message>
feat: add campaign tracking and decision logs for July 2026
- Created CSV file for campaign performance from July 1 to July 21, 2026, detailing ad sets, results, and costs.
- Added markdown documentation for ongoing and completed campaigns, emphasizing follower growth as the primary objective.
- Established a decision log to record strategic choices and learnings, including the shift from Facebook to Instagram for ad spend.
- Documented the current state of the account, including objectives, budget, and performance metrics for June 2026.
</commit_message>
<xml_diff>
--- a/Shopping Cidade/operations/reunioes/reuniao_junho_shopping_cidade.pptx
+++ b/Shopping Cidade/operations/reunioes/reuniao_junho_shopping_cidade.pptx
@@ -4464,7 +4464,7 @@
                 <a:ea typeface="Poppins" pitchFamily="34" charset="-122"/>
                 <a:cs typeface="Poppins" pitchFamily="34" charset="-120"/>
               </a:rPr>
-              <a:t>antiga</a:t>
+              <a:t>antigas</a:t>
             </a:r>
             <a:endParaRPr lang="en-US" sz="1700" dirty="0"/>
           </a:p>
@@ -5165,7 +5165,18 @@
                 <a:ea typeface="Poppins" pitchFamily="34" charset="-122"/>
                 <a:cs typeface="Poppins" pitchFamily="34" charset="-120"/>
               </a:rPr>
-              <a:t>O PLANO DE JULHO</a:t>
+              <a:t>O PLANO DE </a:t>
+            </a:r>
+            <a:r>
+              <a:rPr lang="en-US" sz="1200" b="1" kern="0" spc="200" dirty="0" smtClean="0">
+                <a:solidFill>
+                  <a:srgbClr val="E01C4C"/>
+                </a:solidFill>
+                <a:latin typeface="Poppins" pitchFamily="34" charset="0"/>
+                <a:ea typeface="Poppins" pitchFamily="34" charset="-122"/>
+                <a:cs typeface="Poppins" pitchFamily="34" charset="-120"/>
+              </a:rPr>
+              <a:t>JULHO/AGOSTO</a:t>
             </a:r>
             <a:endParaRPr lang="en-US" sz="1200" dirty="0"/>
           </a:p>
@@ -5321,7 +5332,7 @@
               <a:buNone/>
             </a:pPr>
             <a:r>
-              <a:rPr lang="en-US" sz="1350" dirty="0">
+              <a:rPr lang="en-US" sz="1350" dirty="0" err="1" smtClean="0">
                 <a:solidFill>
                   <a:srgbClr val="1A1A1A"/>
                 </a:solidFill>
@@ -5329,7 +5340,18 @@
                 <a:ea typeface="Poppins" pitchFamily="34" charset="-122"/>
                 <a:cs typeface="Poppins" pitchFamily="34" charset="-120"/>
               </a:rPr>
-              <a:t>Praticamente não mexemos ainda. </a:t>
+              <a:t>Início</a:t>
+            </a:r>
+            <a:r>
+              <a:rPr lang="en-US" sz="1350" dirty="0" smtClean="0">
+                <a:solidFill>
+                  <a:srgbClr val="1A1A1A"/>
+                </a:solidFill>
+                <a:latin typeface="Poppins" pitchFamily="34" charset="0"/>
+                <a:ea typeface="Poppins" pitchFamily="34" charset="-122"/>
+                <a:cs typeface="Poppins" pitchFamily="34" charset="-120"/>
+              </a:rPr>
+              <a:t> da </a:t>
             </a:r>
             <a:r>
               <a:rPr lang="en-US" sz="1350" dirty="0" err="1" smtClean="0">
@@ -5340,7 +5362,7 @@
                 <a:ea typeface="Poppins" pitchFamily="34" charset="-122"/>
                 <a:cs typeface="Poppins" pitchFamily="34" charset="-120"/>
               </a:rPr>
-              <a:t>Será</a:t>
+              <a:t>criação</a:t>
             </a:r>
             <a:r>
               <a:rPr lang="en-US" sz="1350" dirty="0" smtClean="0">
@@ -5351,29 +5373,7 @@
                 <a:ea typeface="Poppins" pitchFamily="34" charset="-122"/>
                 <a:cs typeface="Poppins" pitchFamily="34" charset="-120"/>
               </a:rPr>
-              <a:t> </a:t>
-            </a:r>
-            <a:r>
-              <a:rPr lang="en-US" sz="1350" dirty="0" err="1" smtClean="0">
-                <a:solidFill>
-                  <a:srgbClr val="1A1A1A"/>
-                </a:solidFill>
-                <a:latin typeface="Poppins" pitchFamily="34" charset="0"/>
-                <a:ea typeface="Poppins" pitchFamily="34" charset="-122"/>
-                <a:cs typeface="Poppins" pitchFamily="34" charset="-120"/>
-              </a:rPr>
-              <a:t>criado</a:t>
-            </a:r>
-            <a:r>
-              <a:rPr lang="en-US" sz="1350" dirty="0" smtClean="0">
-                <a:solidFill>
-                  <a:srgbClr val="1A1A1A"/>
-                </a:solidFill>
-                <a:latin typeface="Poppins" pitchFamily="34" charset="0"/>
-                <a:ea typeface="Poppins" pitchFamily="34" charset="-122"/>
-                <a:cs typeface="Poppins" pitchFamily="34" charset="-120"/>
-              </a:rPr>
-              <a:t> landing </a:t>
+              <a:t> da landing </a:t>
             </a:r>
             <a:r>
               <a:rPr lang="en-US" sz="1350" dirty="0">

</xml_diff>